<commit_message>
Adding the frontend part, Database Schema, Module Description
</commit_message>
<xml_diff>
--- a/Docs/HireCraft_AI_Week1_Review.pptx
+++ b/Docs/HireCraft_AI_Week1_Review.pptx
@@ -1443,7 +1443,7 @@
         </p:nvSpPr>
         <p:spPr>
           <a:xfrm>
-            <a:off x="0" y="0"/>
+            <a:off x="5938" y="0"/>
             <a:ext cx="3840480" cy="5143500"/>
           </a:xfrm>
           <a:prstGeom prst="roundRect">
@@ -1893,9 +1893,6 @@
             </a:r>
           </a:p>
           <a:p>
-            <a:pPr marL="0" indent="0" algn="l">
-              <a:buNone/>
-            </a:pPr>
             <a:r>
               <a:rPr lang="en-US" sz="950" dirty="0">
                 <a:solidFill>
@@ -1905,7 +1902,7 @@
                 <a:ea typeface="Calibri" pitchFamily="34" charset="-122"/>
                 <a:cs typeface="Calibri" pitchFamily="34" charset="-120"/>
               </a:rPr>
-              <a:t>Janardhan P </a:t>
+              <a:t>Janardhan P (Roll No:212224040128) </a:t>
             </a:r>
             <a:endParaRPr lang="en-US" sz="950" dirty="0"/>
           </a:p>
@@ -5220,7 +5217,7 @@
         </p:nvSpPr>
         <p:spPr>
           <a:xfrm>
-            <a:off x="0" y="0"/>
+            <a:off x="17814" y="0"/>
             <a:ext cx="9144000" cy="5143500"/>
           </a:xfrm>
           <a:prstGeom prst="rect">
@@ -9039,7 +9036,7 @@
         </p:nvSpPr>
         <p:spPr>
           <a:xfrm>
-            <a:off x="457200" y="2075688"/>
+            <a:off x="457200" y="2087564"/>
             <a:ext cx="8229600" cy="566928"/>
           </a:xfrm>
           <a:prstGeom prst="roundRect">

</xml_diff>